<commit_message>
Add scannable QR codes to the 3-minute pitch deck
Rebuild Play, source, and mirror QR PNGs in the generator and embed them on the closing slide, with a small Play code on the title slide.

Co-authored-by: szekangylp <szekangylp@gmail.com>
</commit_message>
<xml_diff>
--- a/docs/教父世家-3分鐘簡報.pptx
+++ b/docs/教父世家-3分鐘簡報.pptx
@@ -522,7 +522,7 @@
           </a:p>
           <a:p>
             <a:r>
-              <a:t>而家就可以玩：yip-lgtm.github.io/family。今日三分鐘：做咩、畫面點樣永遠有人、點做出嚟。</a:t>
+              <a:t>而家就可以玩：右下角掃「玩」QR，或者 yip-lgtm.github.io/family。今日三分鐘：做咩、畫面點樣永遠有人、點做出嚟。</a:t>
             </a:r>
           </a:p>
         </p:txBody>
@@ -677,7 +677,7 @@
           </a:p>
           <a:p>
             <a:r>
-              <a:t>人死功法在。家在，戲就未完。github.io/family。多謝。</a:t>
+              <a:t>人死功法在。家在，戲就未完。掃中間最大個「玩」QR，或者 yip-lgtm.github.io/family。兩邊係源碼同鏡像。多謝。</a:t>
             </a:r>
           </a:p>
         </p:txBody>
@@ -4726,6 +4726,155 @@
           </a:p>
         </p:txBody>
       </p:sp>
+      <p:sp>
+        <p:nvSpPr>
+          <p:cNvPr id="11" name="Rounded Rectangle 10"/>
+          <p:cNvSpPr/>
+          <p:nvPr/>
+        </p:nvSpPr>
+        <p:spPr>
+          <a:xfrm>
+            <a:off x="10570464" y="4718304"/>
+            <a:ext cx="1188720" cy="1188720"/>
+          </a:xfrm>
+          <a:prstGeom prst="roundRect">
+            <a:avLst/>
+          </a:prstGeom>
+          <a:solidFill>
+            <a:srgbClr val="F4E8C8"/>
+          </a:solidFill>
+          <a:ln w="19050">
+            <a:solidFill>
+              <a:srgbClr val="D4AF37"/>
+            </a:solidFill>
+          </a:ln>
+        </p:spPr>
+        <p:style>
+          <a:lnRef idx="1">
+            <a:schemeClr val="accent1"/>
+          </a:lnRef>
+          <a:fillRef idx="3">
+            <a:schemeClr val="accent1"/>
+          </a:fillRef>
+          <a:effectRef idx="2">
+            <a:schemeClr val="accent1"/>
+          </a:effectRef>
+          <a:fontRef idx="minor">
+            <a:schemeClr val="lt1"/>
+          </a:fontRef>
+        </p:style>
+        <p:txBody>
+          <a:bodyPr rtlCol="0" anchor="ctr"/>
+          <a:lstStyle/>
+          <a:p>
+            <a:pPr algn="ctr"/>
+          </a:p>
+        </p:txBody>
+      </p:sp>
+      <p:pic>
+        <p:nvPicPr>
+          <p:cNvPr id="12" name="Picture 11" descr="play.png"/>
+          <p:cNvPicPr>
+            <a:picLocks noChangeAspect="1"/>
+          </p:cNvPicPr>
+          <p:nvPr/>
+        </p:nvPicPr>
+        <p:blipFill>
+          <a:blip r:embed="rId2"/>
+          <a:stretch>
+            <a:fillRect/>
+          </a:stretch>
+        </p:blipFill>
+        <p:spPr>
+          <a:xfrm>
+            <a:off x="10625328" y="4773168"/>
+            <a:ext cx="1078992" cy="1078992"/>
+          </a:xfrm>
+          <a:prstGeom prst="rect">
+            <a:avLst/>
+          </a:prstGeom>
+        </p:spPr>
+      </p:pic>
+      <p:sp>
+        <p:nvSpPr>
+          <p:cNvPr id="13" name="TextBox 12"/>
+          <p:cNvSpPr txBox="1"/>
+          <p:nvPr/>
+        </p:nvSpPr>
+        <p:spPr>
+          <a:xfrm>
+            <a:off x="10424160" y="5916168"/>
+            <a:ext cx="1481328" cy="274320"/>
+          </a:xfrm>
+          <a:prstGeom prst="rect">
+            <a:avLst/>
+          </a:prstGeom>
+          <a:noFill/>
+        </p:spPr>
+        <p:txBody>
+          <a:bodyPr wrap="square">
+            <a:spAutoFit/>
+          </a:bodyPr>
+          <a:lstStyle/>
+          <a:p>
+            <a:pPr algn="ctr">
+              <a:spcAft>
+                <a:spcPts val="600"/>
+              </a:spcAft>
+            </a:pPr>
+            <a:r>
+              <a:rPr sz="1500" b="1">
+                <a:solidFill>
+                  <a:srgbClr val="D4AF37"/>
+                </a:solidFill>
+                <a:latin typeface="Microsoft YaHei"/>
+                <a:ea typeface="Microsoft YaHei"/>
+              </a:rPr>
+              <a:t>玩</a:t>
+            </a:r>
+          </a:p>
+        </p:txBody>
+      </p:sp>
+      <p:sp>
+        <p:nvSpPr>
+          <p:cNvPr id="14" name="TextBox 13"/>
+          <p:cNvSpPr txBox="1"/>
+          <p:nvPr/>
+        </p:nvSpPr>
+        <p:spPr>
+          <a:xfrm>
+            <a:off x="10332720" y="6153912"/>
+            <a:ext cx="1664208" cy="256032"/>
+          </a:xfrm>
+          <a:prstGeom prst="rect">
+            <a:avLst/>
+          </a:prstGeom>
+          <a:noFill/>
+        </p:spPr>
+        <p:txBody>
+          <a:bodyPr wrap="square">
+            <a:spAutoFit/>
+          </a:bodyPr>
+          <a:lstStyle/>
+          <a:p>
+            <a:pPr algn="ctr">
+              <a:spcAft>
+                <a:spcPts val="600"/>
+              </a:spcAft>
+            </a:pPr>
+            <a:r>
+              <a:rPr sz="1100" b="0">
+                <a:solidFill>
+                  <a:srgbClr val="B8A888"/>
+                </a:solidFill>
+                <a:latin typeface="Microsoft YaHei"/>
+                <a:ea typeface="Microsoft YaHei"/>
+              </a:rPr>
+              <a:t>掃碼即玩</a:t>
+            </a:r>
+          </a:p>
+        </p:txBody>
+      </p:sp>
     </p:spTree>
   </p:cSld>
   <p:clrMapOvr>
@@ -5758,8 +5907,8 @@
         </p:nvSpPr>
         <p:spPr>
           <a:xfrm>
-            <a:off x="5696712" y="658368"/>
-            <a:ext cx="749808" cy="749808"/>
+            <a:off x="5696712" y="347472"/>
+            <a:ext cx="640080" cy="640080"/>
           </a:xfrm>
           <a:prstGeom prst="diamond">
             <a:avLst/>
@@ -5803,8 +5952,8 @@
         </p:nvSpPr>
         <p:spPr>
           <a:xfrm>
-            <a:off x="5696712" y="868314"/>
-            <a:ext cx="749808" cy="359907"/>
+            <a:off x="5696712" y="526694"/>
+            <a:ext cx="640080" cy="307238"/>
           </a:xfrm>
           <a:prstGeom prst="rect">
             <a:avLst/>
@@ -5843,8 +5992,8 @@
         </p:nvSpPr>
         <p:spPr>
           <a:xfrm>
-            <a:off x="731520" y="1481328"/>
-            <a:ext cx="10698480" cy="365760"/>
+            <a:off x="731520" y="1024128"/>
+            <a:ext cx="10698480" cy="292608"/>
           </a:xfrm>
           <a:prstGeom prst="rect">
             <a:avLst/>
@@ -5883,8 +6032,8 @@
         </p:nvSpPr>
         <p:spPr>
           <a:xfrm>
-            <a:off x="731520" y="1901952"/>
-            <a:ext cx="10698480" cy="1143000"/>
+            <a:off x="502920" y="1298448"/>
+            <a:ext cx="11155680" cy="658368"/>
           </a:xfrm>
           <a:prstGeom prst="rect">
             <a:avLst/>
@@ -5903,7 +6052,7 @@
               </a:spcAft>
             </a:pPr>
             <a:r>
-              <a:rPr sz="3200" b="1">
+              <a:rPr sz="2800" b="1">
                 <a:solidFill>
                   <a:srgbClr val="D4AF37"/>
                 </a:solidFill>
@@ -5917,14 +6066,83 @@
       </p:sp>
       <p:sp>
         <p:nvSpPr>
-          <p:cNvPr id="8" name="TextBox 7"/>
+          <p:cNvPr id="8" name="Rounded Rectangle 7"/>
+          <p:cNvSpPr/>
+          <p:nvPr/>
+        </p:nvSpPr>
+        <p:spPr>
+          <a:xfrm>
+            <a:off x="1243584" y="2295144"/>
+            <a:ext cx="1554480" cy="1554480"/>
+          </a:xfrm>
+          <a:prstGeom prst="roundRect">
+            <a:avLst/>
+          </a:prstGeom>
+          <a:solidFill>
+            <a:srgbClr val="F4E8C8"/>
+          </a:solidFill>
+          <a:ln w="19050">
+            <a:solidFill>
+              <a:srgbClr val="D4AF37"/>
+            </a:solidFill>
+          </a:ln>
+        </p:spPr>
+        <p:style>
+          <a:lnRef idx="1">
+            <a:schemeClr val="accent1"/>
+          </a:lnRef>
+          <a:fillRef idx="3">
+            <a:schemeClr val="accent1"/>
+          </a:fillRef>
+          <a:effectRef idx="2">
+            <a:schemeClr val="accent1"/>
+          </a:effectRef>
+          <a:fontRef idx="minor">
+            <a:schemeClr val="lt1"/>
+          </a:fontRef>
+        </p:style>
+        <p:txBody>
+          <a:bodyPr rtlCol="0" anchor="ctr"/>
+          <a:lstStyle/>
+          <a:p>
+            <a:pPr algn="ctr"/>
+          </a:p>
+        </p:txBody>
+      </p:sp>
+      <p:pic>
+        <p:nvPicPr>
+          <p:cNvPr id="9" name="Picture 8" descr="source.png"/>
+          <p:cNvPicPr>
+            <a:picLocks noChangeAspect="1"/>
+          </p:cNvPicPr>
+          <p:nvPr/>
+        </p:nvPicPr>
+        <p:blipFill>
+          <a:blip r:embed="rId2"/>
+          <a:stretch>
+            <a:fillRect/>
+          </a:stretch>
+        </p:blipFill>
+        <p:spPr>
+          <a:xfrm>
+            <a:off x="1298448" y="2350008"/>
+            <a:ext cx="1444752" cy="1444752"/>
+          </a:xfrm>
+          <a:prstGeom prst="rect">
+            <a:avLst/>
+          </a:prstGeom>
+        </p:spPr>
+      </p:pic>
+      <p:sp>
+        <p:nvSpPr>
+          <p:cNvPr id="10" name="TextBox 9"/>
           <p:cNvSpPr txBox="1"/>
           <p:nvPr/>
         </p:nvSpPr>
         <p:spPr>
           <a:xfrm>
-            <a:off x="731520" y="3154680"/>
-            <a:ext cx="10698480" cy="1554480"/>
+            <a:off x="795528" y="3858768"/>
+            <a:ext cx="2450592" cy="274320"/>
           </a:xfrm>
           <a:prstGeom prst="rect">
             <a:avLst/>
@@ -5943,16 +6161,39 @@
               </a:spcAft>
             </a:pPr>
             <a:r>
-              <a:rPr sz="2000" b="1">
-                <a:solidFill>
-                  <a:srgbClr val="7EC8C3"/>
-                </a:solidFill>
-                <a:latin typeface="Microsoft YaHei"/>
-                <a:ea typeface="Microsoft YaHei"/>
-              </a:rPr>
-              <a:t>玩　　https://yip-lgtm.github.io/family/</a:t>
-            </a:r>
-          </a:p>
+              <a:rPr sz="1500" b="1">
+                <a:solidFill>
+                  <a:srgbClr val="D4AF37"/>
+                </a:solidFill>
+                <a:latin typeface="Microsoft YaHei"/>
+                <a:ea typeface="Microsoft YaHei"/>
+              </a:rPr>
+              <a:t>源碼</a:t>
+            </a:r>
+          </a:p>
+        </p:txBody>
+      </p:sp>
+      <p:sp>
+        <p:nvSpPr>
+          <p:cNvPr id="11" name="TextBox 10"/>
+          <p:cNvSpPr txBox="1"/>
+          <p:nvPr/>
+        </p:nvSpPr>
+        <p:spPr>
+          <a:xfrm>
+            <a:off x="704088" y="4096512"/>
+            <a:ext cx="2633472" cy="256032"/>
+          </a:xfrm>
+          <a:prstGeom prst="rect">
+            <a:avLst/>
+          </a:prstGeom>
+          <a:noFill/>
+        </p:spPr>
+        <p:txBody>
+          <a:bodyPr wrap="square">
+            <a:spAutoFit/>
+          </a:bodyPr>
+          <a:lstStyle/>
           <a:p>
             <a:pPr algn="ctr">
               <a:spcAft>
@@ -5960,16 +6201,108 @@
               </a:spcAft>
             </a:pPr>
             <a:r>
-              <a:rPr sz="1800" b="0">
+              <a:rPr sz="1100" b="0">
                 <a:solidFill>
                   <a:srgbClr val="B8A888"/>
                 </a:solidFill>
                 <a:latin typeface="Microsoft YaHei"/>
                 <a:ea typeface="Microsoft YaHei"/>
               </a:rPr>
-              <a:t>源碼　https://github.com/yip-lgtm/family.git</a:t>
-            </a:r>
-          </a:p>
+              <a:t>github.com/yip-lgtm/family</a:t>
+            </a:r>
+          </a:p>
+        </p:txBody>
+      </p:sp>
+      <p:sp>
+        <p:nvSpPr>
+          <p:cNvPr id="12" name="Rounded Rectangle 11"/>
+          <p:cNvSpPr/>
+          <p:nvPr/>
+        </p:nvSpPr>
+        <p:spPr>
+          <a:xfrm>
+            <a:off x="4997196" y="1975104"/>
+            <a:ext cx="2194559" cy="2194559"/>
+          </a:xfrm>
+          <a:prstGeom prst="roundRect">
+            <a:avLst/>
+          </a:prstGeom>
+          <a:solidFill>
+            <a:srgbClr val="F4E8C8"/>
+          </a:solidFill>
+          <a:ln w="28575">
+            <a:solidFill>
+              <a:srgbClr val="D4AF37"/>
+            </a:solidFill>
+          </a:ln>
+        </p:spPr>
+        <p:style>
+          <a:lnRef idx="1">
+            <a:schemeClr val="accent1"/>
+          </a:lnRef>
+          <a:fillRef idx="3">
+            <a:schemeClr val="accent1"/>
+          </a:fillRef>
+          <a:effectRef idx="2">
+            <a:schemeClr val="accent1"/>
+          </a:effectRef>
+          <a:fontRef idx="minor">
+            <a:schemeClr val="lt1"/>
+          </a:fontRef>
+        </p:style>
+        <p:txBody>
+          <a:bodyPr rtlCol="0" anchor="ctr"/>
+          <a:lstStyle/>
+          <a:p>
+            <a:pPr algn="ctr"/>
+          </a:p>
+        </p:txBody>
+      </p:sp>
+      <p:pic>
+        <p:nvPicPr>
+          <p:cNvPr id="13" name="Picture 12" descr="play.png"/>
+          <p:cNvPicPr>
+            <a:picLocks noChangeAspect="1"/>
+          </p:cNvPicPr>
+          <p:nvPr/>
+        </p:nvPicPr>
+        <p:blipFill>
+          <a:blip r:embed="rId3"/>
+          <a:stretch>
+            <a:fillRect/>
+          </a:stretch>
+        </p:blipFill>
+        <p:spPr>
+          <a:xfrm>
+            <a:off x="5052060" y="2029968"/>
+            <a:ext cx="2084831" cy="2084831"/>
+          </a:xfrm>
+          <a:prstGeom prst="rect">
+            <a:avLst/>
+          </a:prstGeom>
+        </p:spPr>
+      </p:pic>
+      <p:sp>
+        <p:nvSpPr>
+          <p:cNvPr id="14" name="TextBox 13"/>
+          <p:cNvSpPr txBox="1"/>
+          <p:nvPr/>
+        </p:nvSpPr>
+        <p:spPr>
+          <a:xfrm>
+            <a:off x="4549140" y="4178807"/>
+            <a:ext cx="3090671" cy="274320"/>
+          </a:xfrm>
+          <a:prstGeom prst="rect">
+            <a:avLst/>
+          </a:prstGeom>
+          <a:noFill/>
+        </p:spPr>
+        <p:txBody>
+          <a:bodyPr wrap="square">
+            <a:spAutoFit/>
+          </a:bodyPr>
+          <a:lstStyle/>
           <a:p>
             <a:pPr algn="ctr">
               <a:spcAft>
@@ -5977,28 +6310,217 @@
               </a:spcAft>
             </a:pPr>
             <a:r>
-              <a:rPr sz="1600" b="0">
+              <a:rPr sz="1500" b="1">
+                <a:solidFill>
+                  <a:srgbClr val="D4AF37"/>
+                </a:solidFill>
+                <a:latin typeface="Microsoft YaHei"/>
+                <a:ea typeface="Microsoft YaHei"/>
+              </a:rPr>
+              <a:t>玩</a:t>
+            </a:r>
+          </a:p>
+        </p:txBody>
+      </p:sp>
+      <p:sp>
+        <p:nvSpPr>
+          <p:cNvPr id="15" name="TextBox 14"/>
+          <p:cNvSpPr txBox="1"/>
+          <p:nvPr/>
+        </p:nvSpPr>
+        <p:spPr>
+          <a:xfrm>
+            <a:off x="4457700" y="4416551"/>
+            <a:ext cx="3273551" cy="256032"/>
+          </a:xfrm>
+          <a:prstGeom prst="rect">
+            <a:avLst/>
+          </a:prstGeom>
+          <a:noFill/>
+        </p:spPr>
+        <p:txBody>
+          <a:bodyPr wrap="square">
+            <a:spAutoFit/>
+          </a:bodyPr>
+          <a:lstStyle/>
+          <a:p>
+            <a:pPr algn="ctr">
+              <a:spcAft>
+                <a:spcPts val="600"/>
+              </a:spcAft>
+            </a:pPr>
+            <a:r>
+              <a:rPr sz="1100" b="0">
                 <a:solidFill>
                   <a:srgbClr val="B8A888"/>
                 </a:solidFill>
                 <a:latin typeface="Microsoft YaHei"/>
                 <a:ea typeface="Microsoft YaHei"/>
               </a:rPr>
-              <a:t>鏡像　https://github.com/yip-lgtm/qi-lineage</a:t>
-            </a:r>
-          </a:p>
-        </p:txBody>
-      </p:sp>
-      <p:sp>
-        <p:nvSpPr>
-          <p:cNvPr id="9" name="TextBox 8"/>
+              <a:t>yip-lgtm.github.io/family</a:t>
+            </a:r>
+          </a:p>
+        </p:txBody>
+      </p:sp>
+      <p:sp>
+        <p:nvSpPr>
+          <p:cNvPr id="16" name="Rounded Rectangle 15"/>
+          <p:cNvSpPr/>
+          <p:nvPr/>
+        </p:nvSpPr>
+        <p:spPr>
+          <a:xfrm>
+            <a:off x="9381744" y="2295144"/>
+            <a:ext cx="1554480" cy="1554480"/>
+          </a:xfrm>
+          <a:prstGeom prst="roundRect">
+            <a:avLst/>
+          </a:prstGeom>
+          <a:solidFill>
+            <a:srgbClr val="F4E8C8"/>
+          </a:solidFill>
+          <a:ln w="19050">
+            <a:solidFill>
+              <a:srgbClr val="D4AF37"/>
+            </a:solidFill>
+          </a:ln>
+        </p:spPr>
+        <p:style>
+          <a:lnRef idx="1">
+            <a:schemeClr val="accent1"/>
+          </a:lnRef>
+          <a:fillRef idx="3">
+            <a:schemeClr val="accent1"/>
+          </a:fillRef>
+          <a:effectRef idx="2">
+            <a:schemeClr val="accent1"/>
+          </a:effectRef>
+          <a:fontRef idx="minor">
+            <a:schemeClr val="lt1"/>
+          </a:fontRef>
+        </p:style>
+        <p:txBody>
+          <a:bodyPr rtlCol="0" anchor="ctr"/>
+          <a:lstStyle/>
+          <a:p>
+            <a:pPr algn="ctr"/>
+          </a:p>
+        </p:txBody>
+      </p:sp>
+      <p:pic>
+        <p:nvPicPr>
+          <p:cNvPr id="17" name="Picture 16" descr="mirror.png"/>
+          <p:cNvPicPr>
+            <a:picLocks noChangeAspect="1"/>
+          </p:cNvPicPr>
+          <p:nvPr/>
+        </p:nvPicPr>
+        <p:blipFill>
+          <a:blip r:embed="rId4"/>
+          <a:stretch>
+            <a:fillRect/>
+          </a:stretch>
+        </p:blipFill>
+        <p:spPr>
+          <a:xfrm>
+            <a:off x="9436608" y="2350008"/>
+            <a:ext cx="1444752" cy="1444752"/>
+          </a:xfrm>
+          <a:prstGeom prst="rect">
+            <a:avLst/>
+          </a:prstGeom>
+        </p:spPr>
+      </p:pic>
+      <p:sp>
+        <p:nvSpPr>
+          <p:cNvPr id="18" name="TextBox 17"/>
           <p:cNvSpPr txBox="1"/>
           <p:nvPr/>
         </p:nvSpPr>
         <p:spPr>
           <a:xfrm>
-            <a:off x="731520" y="4937760"/>
-            <a:ext cx="10698480" cy="914400"/>
+            <a:off x="8933688" y="3858768"/>
+            <a:ext cx="2450592" cy="274320"/>
+          </a:xfrm>
+          <a:prstGeom prst="rect">
+            <a:avLst/>
+          </a:prstGeom>
+          <a:noFill/>
+        </p:spPr>
+        <p:txBody>
+          <a:bodyPr wrap="square">
+            <a:spAutoFit/>
+          </a:bodyPr>
+          <a:lstStyle/>
+          <a:p>
+            <a:pPr algn="ctr">
+              <a:spcAft>
+                <a:spcPts val="600"/>
+              </a:spcAft>
+            </a:pPr>
+            <a:r>
+              <a:rPr sz="1500" b="1">
+                <a:solidFill>
+                  <a:srgbClr val="D4AF37"/>
+                </a:solidFill>
+                <a:latin typeface="Microsoft YaHei"/>
+                <a:ea typeface="Microsoft YaHei"/>
+              </a:rPr>
+              <a:t>鏡像</a:t>
+            </a:r>
+          </a:p>
+        </p:txBody>
+      </p:sp>
+      <p:sp>
+        <p:nvSpPr>
+          <p:cNvPr id="19" name="TextBox 18"/>
+          <p:cNvSpPr txBox="1"/>
+          <p:nvPr/>
+        </p:nvSpPr>
+        <p:spPr>
+          <a:xfrm>
+            <a:off x="8842248" y="4096512"/>
+            <a:ext cx="2633472" cy="256032"/>
+          </a:xfrm>
+          <a:prstGeom prst="rect">
+            <a:avLst/>
+          </a:prstGeom>
+          <a:noFill/>
+        </p:spPr>
+        <p:txBody>
+          <a:bodyPr wrap="square">
+            <a:spAutoFit/>
+          </a:bodyPr>
+          <a:lstStyle/>
+          <a:p>
+            <a:pPr algn="ctr">
+              <a:spcAft>
+                <a:spcPts val="600"/>
+              </a:spcAft>
+            </a:pPr>
+            <a:r>
+              <a:rPr sz="1100" b="0">
+                <a:solidFill>
+                  <a:srgbClr val="B8A888"/>
+                </a:solidFill>
+                <a:latin typeface="Microsoft YaHei"/>
+                <a:ea typeface="Microsoft YaHei"/>
+              </a:rPr>
+              <a:t>github.com/yip-lgtm/qi-lineage</a:t>
+            </a:r>
+          </a:p>
+        </p:txBody>
+      </p:sp>
+      <p:sp>
+        <p:nvSpPr>
+          <p:cNvPr id="20" name="TextBox 19"/>
+          <p:cNvSpPr txBox="1"/>
+          <p:nvPr/>
+        </p:nvSpPr>
+        <p:spPr>
+          <a:xfrm>
+            <a:off x="731520" y="5138928"/>
+            <a:ext cx="10698480" cy="1051560"/>
           </a:xfrm>
           <a:prstGeom prst="rect">
             <a:avLst/>

</xml_diff>